<commit_message>
text fidelity: join spans by gap, truncate captions on word boundaries
Reading an actual render caught three defects that structural checks passed:

- spans were joined with '' to fix 'PPTA|GENT' but that produced 'Stage|I:' ->
  'StageI'. The gap between span boxes now decides (join_spans), so both cases
  are right. 'StageI' that remains comes from the source PDF's own text layer.
- captions were cut at 220 characters mid-word; now cut at a word boundary
- dehyphenation kept the hyphen for any 2-letter prefix, turning 'ex-\ntract'
  into 'ex-tract'; the keep-list now governs, so it becomes 'extract'

Also documents the render path that works here: kite render is broken, convert
plus PyMuPDF is not. 61 tests.
</commit_message>
<xml_diff>
--- a/out/PPTAgent_2501.03936.pptx
+++ b/out/PPTAgent_2501.03936.pptx
@@ -790,7 +790,7 @@
           <a:lstStyle/>
           <a:p>
             <a:r>
-              <a:t>This slide covers experiment. Open with: All open-source LLMs are deployed us-ing the VLLM framework on NVIDIA A100 GPUs. Then move to: Each configuration generates 50 presentations (5 domains × 10 input documents), as they do .... Target roughly 90 seconds here.</a:t>
+              <a:t>This slide covers experiment. Open with: All open-source LLMs are deployed using the VLLM framework on NVIDIA A100 GPUs. Then move to: Each configuration generates 50 presentations (5 domains × 10 input documents), as they do .... Target roughly 90 seconds here.</a:t>
             </a:r>
           </a:p>
         </p:txBody>
@@ -1000,7 +1000,7 @@
           <a:lstStyle/>
           <a:p>
             <a:r>
-              <a:t>This slide covers conclusion. Open with: Our ex-periments across data from multiple domains have demonstrated the superiority of our method. Then move to: Moreover, we propose PPTEVAL to provide quantitative metrics for assessing presentation quality. Target roughly 90 seconds here.</a:t>
+              <a:t>This slide covers conclusion. Open with: Our experiments across data from multiple domains have demonstrated the superiority of our method. Then move to: Moreover, we propose PPTEVAL to provide quantitative metrics for assessing presentation quality. Target roughly 90 seconds here.</a:t>
             </a:r>
           </a:p>
         </p:txBody>
@@ -4479,7 +4479,7 @@
                 </a:solidFill>
                 <a:latin typeface="Helvetica Neue"/>
               </a:rPr>
-              <a:t>PPTAGENT first analyzes reference presentations to ex-tract slide-level functional types and content schemas, then ...</a:t>
+              <a:t>PPTAGENT first analyzes reference presentations to extract slide-level functional types and content schemas, then ...</a:t>
             </a:r>
           </a:p>
           <a:p>
@@ -4616,7 +4616,7 @@
                 </a:solidFill>
                 <a:latin typeface="Helvetica Neue"/>
               </a:rPr>
-              <a:t>Figure 2: Overview of the PPTAGENT workflow. StageI: Presentation Analysis involves analyzing the input presentation to cluster slides into groups and extract their content schemas. Stage II: Presentation Generation gene</a:t>
+              <a:t>Figure 2: Overview of the PPTAGENT workflow. StageI: Presentation Analysis involves analyzing the input presentation to cluster slides into groups and extract their content schemas. Stage II: Presentation ...</a:t>
             </a:r>
           </a:p>
         </p:txBody>
@@ -4952,7 +4952,7 @@
                 </a:solidFill>
                 <a:latin typeface="Helvetica Neue"/>
               </a:rPr>
-              <a:t>Re-sults demonstrate that PPTAGENT generates high-quality presentations, achieving an average score of 3.67 for ...</a:t>
+              <a:t>Results demonstrate that PPTAGENT generates high-quality presentations, achieving an average score of 3.67 for ...</a:t>
             </a:r>
           </a:p>
         </p:txBody>
@@ -5593,7 +5593,7 @@
                 </a:solidFill>
                 <a:latin typeface="Helvetica Neue"/>
               </a:rPr>
-              <a:t>All open-source LLMs are deployed us-ing the VLLM framework on NVIDIA A100 GPUs</a:t>
+              <a:t>All open-source LLMs are deployed using the VLLM framework on NVIDIA A100 GPUs</a:t>
             </a:r>
           </a:p>
           <a:p>
@@ -6601,7 +6601,7 @@
                 </a:solidFill>
                 <a:latin typeface="Helvetica Neue"/>
               </a:rPr>
-              <a:t>Our ex-periments across data from multiple domains have demonstrated the superiority of our method</a:t>
+              <a:t>Our experiments across data from multiple domains have demonstrated the superiority of our method</a:t>
             </a:r>
           </a:p>
           <a:p>

</xml_diff>